<commit_message>
feat: add spark ml fare prediction
</commit_message>
<xml_diff>
--- a/docs/Urban_Mobility_Big_Data_Analytics_Jash_Parekh_Updated.pptx
+++ b/docs/Urban_Mobility_Big_Data_Analytics_Jash_Parekh_Updated.pptx
@@ -9227,7 +9227,7 @@
                 </a:solidFill>
                 <a:latin typeface="Aptos"/>
               </a:rPr>
-              <a:t>The two capabilities shown in the roadmap are now working features in the project.</a:t>
+              <a:t>The map, streaming, and predictive analytics capabilities are now working features in the project.</a:t>
             </a:r>
           </a:p>
         </p:txBody>
@@ -9812,7 +9812,7 @@
                 </a:solidFill>
                 <a:latin typeface="Aptos"/>
               </a:rPr>
-              <a:t>Next roadmap item: predict fare or trip duration from trip features.</a:t>
+              <a:t>Implemented with linear regression, model metrics, and sample predictions.</a:t>
             </a:r>
           </a:p>
         </p:txBody>
@@ -10730,7 +10730,85 @@
       </p:sp>
       <p:sp>
         <p:nvSpPr>
-          <p:cNvPr id="18" name="TextBox 17"/>
+          <p:cNvPr id="18" name="Oval 17"/>
+          <p:cNvSpPr/>
+          <p:nvPr/>
+        </p:nvSpPr>
+        <p:spPr>
+          <a:xfrm>
+            <a:off x="1051560" y="4361688"/>
+            <a:ext cx="91440" cy="91440"/>
+          </a:xfrm>
+          <a:prstGeom prst="ellipse">
+            <a:avLst/>
+          </a:prstGeom>
+          <a:solidFill>
+            <a:srgbClr val="197C73"/>
+          </a:solidFill>
+          <a:ln>
+            <a:noFill/>
+          </a:ln>
+        </p:spPr>
+        <p:style>
+          <a:lnRef idx="1">
+            <a:schemeClr val="accent1"/>
+          </a:lnRef>
+          <a:fillRef idx="3">
+            <a:schemeClr val="accent1"/>
+          </a:fillRef>
+          <a:effectRef idx="2">
+            <a:schemeClr val="accent1"/>
+          </a:effectRef>
+          <a:fontRef idx="minor">
+            <a:schemeClr val="lt1"/>
+          </a:fontRef>
+        </p:style>
+        <p:txBody>
+          <a:bodyPr rtlCol="0" anchor="ctr"/>
+          <a:lstStyle/>
+          <a:p>
+            <a:pPr algn="ctr"/>
+          </a:p>
+        </p:txBody>
+      </p:sp>
+      <p:sp>
+        <p:nvSpPr>
+          <p:cNvPr id="19" name="TextBox 18"/>
+          <p:cNvSpPr txBox="1"/>
+          <p:nvPr/>
+        </p:nvSpPr>
+        <p:spPr>
+          <a:xfrm>
+            <a:off x="1252728" y="4251960"/>
+            <a:ext cx="9582911" cy="301752"/>
+          </a:xfrm>
+          <a:prstGeom prst="rect">
+            <a:avLst/>
+          </a:prstGeom>
+          <a:noFill/>
+        </p:spPr>
+        <p:txBody>
+          <a:bodyPr wrap="square" lIns="36576" rIns="36576" tIns="36576" bIns="36576" anchor="t">
+            <a:spAutoFit/>
+          </a:bodyPr>
+          <a:lstStyle/>
+          <a:p>
+            <a:pPr algn="l"/>
+            <a:r>
+              <a:rPr sz="1600" b="0" i="0">
+                <a:solidFill>
+                  <a:srgbClr val="FFFFFF"/>
+                </a:solidFill>
+                <a:latin typeface="Aptos"/>
+              </a:rPr>
+              <a:t>Spark ML provides a fare prediction model with RMSE, MAE, and R² metrics.</a:t>
+            </a:r>
+          </a:p>
+        </p:txBody>
+      </p:sp>
+      <p:sp>
+        <p:nvSpPr>
+          <p:cNvPr id="20" name="TextBox 19"/>
           <p:cNvSpPr txBox="1"/>
           <p:nvPr/>
         </p:nvSpPr>
@@ -10765,7 +10843,7 @@
       </p:sp>
       <p:sp>
         <p:nvSpPr>
-          <p:cNvPr id="19" name="TextBox 18"/>
+          <p:cNvPr id="21" name="TextBox 20"/>
           <p:cNvSpPr txBox="1"/>
           <p:nvPr/>
         </p:nvSpPr>
@@ -10800,7 +10878,7 @@
       </p:sp>
       <p:sp>
         <p:nvSpPr>
-          <p:cNvPr id="20" name="TextBox 19"/>
+          <p:cNvPr id="22" name="TextBox 21"/>
           <p:cNvSpPr txBox="1"/>
           <p:nvPr/>
         </p:nvSpPr>
@@ -11704,6 +11782,84 @@
                 </a:solidFill>
                 <a:latin typeface="Aptos"/>
               </a:rPr>
+              <a:t>ml_results collection — fare prediction metrics</a:t>
+            </a:r>
+          </a:p>
+        </p:txBody>
+      </p:sp>
+      <p:sp>
+        <p:nvSpPr>
+          <p:cNvPr id="24" name="Oval 23"/>
+          <p:cNvSpPr/>
+          <p:nvPr/>
+        </p:nvSpPr>
+        <p:spPr>
+          <a:xfrm>
+            <a:off x="6812280" y="4681728"/>
+            <a:ext cx="91440" cy="91440"/>
+          </a:xfrm>
+          <a:prstGeom prst="ellipse">
+            <a:avLst/>
+          </a:prstGeom>
+          <a:solidFill>
+            <a:srgbClr val="197C73"/>
+          </a:solidFill>
+          <a:ln>
+            <a:noFill/>
+          </a:ln>
+        </p:spPr>
+        <p:style>
+          <a:lnRef idx="1">
+            <a:schemeClr val="accent1"/>
+          </a:lnRef>
+          <a:fillRef idx="3">
+            <a:schemeClr val="accent1"/>
+          </a:fillRef>
+          <a:effectRef idx="2">
+            <a:schemeClr val="accent1"/>
+          </a:effectRef>
+          <a:fontRef idx="minor">
+            <a:schemeClr val="lt1"/>
+          </a:fontRef>
+        </p:style>
+        <p:txBody>
+          <a:bodyPr rtlCol="0" anchor="ctr"/>
+          <a:lstStyle/>
+          <a:p>
+            <a:pPr algn="ctr"/>
+          </a:p>
+        </p:txBody>
+      </p:sp>
+      <p:sp>
+        <p:nvSpPr>
+          <p:cNvPr id="25" name="TextBox 24"/>
+          <p:cNvSpPr txBox="1"/>
+          <p:nvPr/>
+        </p:nvSpPr>
+        <p:spPr>
+          <a:xfrm>
+            <a:off x="7013448" y="4572000"/>
+            <a:ext cx="3913632" cy="301752"/>
+          </a:xfrm>
+          <a:prstGeom prst="rect">
+            <a:avLst/>
+          </a:prstGeom>
+          <a:noFill/>
+        </p:spPr>
+        <p:txBody>
+          <a:bodyPr wrap="square" lIns="36576" rIns="36576" tIns="36576" bIns="36576" anchor="t">
+            <a:spAutoFit/>
+          </a:bodyPr>
+          <a:lstStyle/>
+          <a:p>
+            <a:pPr algn="l"/>
+            <a:r>
+              <a:rPr sz="1100" b="0" i="0">
+                <a:solidFill>
+                  <a:srgbClr val="10202C"/>
+                </a:solidFill>
+                <a:latin typeface="Aptos"/>
+              </a:rPr>
               <a:t>docs/project_report.md — written report</a:t>
             </a:r>
           </a:p>
@@ -11711,7 +11867,7 @@
       </p:sp>
       <p:sp>
         <p:nvSpPr>
-          <p:cNvPr id="24" name="TextBox 23"/>
+          <p:cNvPr id="26" name="TextBox 25"/>
           <p:cNvSpPr txBox="1"/>
           <p:nvPr/>
         </p:nvSpPr>
@@ -11746,7 +11902,7 @@
       </p:sp>
       <p:sp>
         <p:nvSpPr>
-          <p:cNvPr id="25" name="TextBox 24"/>
+          <p:cNvPr id="27" name="TextBox 26"/>
           <p:cNvSpPr txBox="1"/>
           <p:nvPr/>
         </p:nvSpPr>

</xml_diff>

<commit_message>
feat: add interactive fare prediction
</commit_message>
<xml_diff>
--- a/docs/Urban_Mobility_Big_Data_Analytics_Jash_Parekh_Updated.pptx
+++ b/docs/Urban_Mobility_Big_Data_Analytics_Jash_Parekh_Updated.pptx
@@ -10808,7 +10808,85 @@
       </p:sp>
       <p:sp>
         <p:nvSpPr>
-          <p:cNvPr id="20" name="TextBox 19"/>
+          <p:cNvPr id="20" name="Oval 19"/>
+          <p:cNvSpPr/>
+          <p:nvPr/>
+        </p:nvSpPr>
+        <p:spPr>
+          <a:xfrm>
+            <a:off x="1051560" y="4745736"/>
+            <a:ext cx="91440" cy="91440"/>
+          </a:xfrm>
+          <a:prstGeom prst="ellipse">
+            <a:avLst/>
+          </a:prstGeom>
+          <a:solidFill>
+            <a:srgbClr val="197C73"/>
+          </a:solidFill>
+          <a:ln>
+            <a:noFill/>
+          </a:ln>
+        </p:spPr>
+        <p:style>
+          <a:lnRef idx="1">
+            <a:schemeClr val="accent1"/>
+          </a:lnRef>
+          <a:fillRef idx="3">
+            <a:schemeClr val="accent1"/>
+          </a:fillRef>
+          <a:effectRef idx="2">
+            <a:schemeClr val="accent1"/>
+          </a:effectRef>
+          <a:fontRef idx="minor">
+            <a:schemeClr val="lt1"/>
+          </a:fontRef>
+        </p:style>
+        <p:txBody>
+          <a:bodyPr rtlCol="0" anchor="ctr"/>
+          <a:lstStyle/>
+          <a:p>
+            <a:pPr algn="ctr"/>
+          </a:p>
+        </p:txBody>
+      </p:sp>
+      <p:sp>
+        <p:nvSpPr>
+          <p:cNvPr id="21" name="TextBox 20"/>
+          <p:cNvSpPr txBox="1"/>
+          <p:nvPr/>
+        </p:nvSpPr>
+        <p:spPr>
+          <a:xfrm>
+            <a:off x="1252728" y="4636008"/>
+            <a:ext cx="9582911" cy="301752"/>
+          </a:xfrm>
+          <a:prstGeom prst="rect">
+            <a:avLst/>
+          </a:prstGeom>
+          <a:noFill/>
+        </p:spPr>
+        <p:txBody>
+          <a:bodyPr wrap="square" lIns="36576" rIns="36576" tIns="36576" bIns="36576" anchor="t">
+            <a:spAutoFit/>
+          </a:bodyPr>
+          <a:lstStyle/>
+          <a:p>
+            <a:pPr algn="l"/>
+            <a:r>
+              <a:rPr sz="1600" b="0" i="0">
+                <a:solidFill>
+                  <a:srgbClr val="FFFFFF"/>
+                </a:solidFill>
+                <a:latin typeface="Aptos"/>
+              </a:rPr>
+              <a:t>A live “Try a trip” form returns an estimated fare from the trained model.</a:t>
+            </a:r>
+          </a:p>
+        </p:txBody>
+      </p:sp>
+      <p:sp>
+        <p:nvSpPr>
+          <p:cNvPr id="22" name="TextBox 21"/>
           <p:cNvSpPr txBox="1"/>
           <p:nvPr/>
         </p:nvSpPr>
@@ -10843,7 +10921,7 @@
       </p:sp>
       <p:sp>
         <p:nvSpPr>
-          <p:cNvPr id="21" name="TextBox 20"/>
+          <p:cNvPr id="23" name="TextBox 22"/>
           <p:cNvSpPr txBox="1"/>
           <p:nvPr/>
         </p:nvSpPr>
@@ -10878,7 +10956,7 @@
       </p:sp>
       <p:sp>
         <p:nvSpPr>
-          <p:cNvPr id="22" name="TextBox 21"/>
+          <p:cNvPr id="24" name="TextBox 23"/>
           <p:cNvSpPr txBox="1"/>
           <p:nvPr/>
         </p:nvSpPr>

</xml_diff>